<commit_message>
Balance deck track framing
</commit_message>
<xml_diff>
--- a/goodco-project-overview.pptx
+++ b/goodco-project-overview.pptx
@@ -4321,7 +4321,7 @@
                 </a:solidFill>
                 <a:latin typeface="Aptos"/>
               </a:rPr>
-              <a:t>The inventory work is not a side quest. It is the trust layer required before pantries can share food.</a:t>
+              <a:t>Inventory is the trust layer that makes pantry-to-pantry movement safe enough to use.</a:t>
             </a:r>
           </a:p>
         </p:txBody>
@@ -4400,7 +4400,7 @@
                 </a:solidFill>
                 <a:latin typeface="Aptos"/>
               </a:rPr>
-              <a:t>Primary fit</a:t>
+              <a:t>Primary problem</a:t>
             </a:r>
           </a:p>
         </p:txBody>
@@ -4507,7 +4507,7 @@
               </a:defRPr>
             </a:pPr>
             <a:r>
-              <a:t>GoodCo applies this at the pantry level.</a:t>
+              <a:t>GoodCo solves this at the pantry level.</a:t>
             </a:r>
           </a:p>
           <a:p>
@@ -4618,7 +4618,7 @@
                 </a:solidFill>
                 <a:latin typeface="Aptos"/>
               </a:rPr>
-              <a:t>Supporting fit</a:t>
+              <a:t>Enabling foundation</a:t>
             </a:r>
           </a:p>
         </p:txBody>
@@ -4691,7 +4691,7 @@
               </a:defRPr>
             </a:pPr>
             <a:r>
-              <a:t>6: receiving creates the trusted lot.</a:t>
+              <a:t>Receiving creates the trusted lot.</a:t>
             </a:r>
           </a:p>
           <a:p>
@@ -4707,7 +4707,7 @@
               </a:defRPr>
             </a:pPr>
             <a:r>
-              <a:t>9: date and shelf-life capture at receiving.</a:t>
+              <a:t>Date and shelf-life capture show urgency.</a:t>
             </a:r>
           </a:p>
           <a:p>
@@ -4723,7 +4723,7 @@
               </a:defRPr>
             </a:pPr>
             <a:r>
-              <a:t>10: expiring view shows what should move.</a:t>
+              <a:t>Expiring view shows what should move.</a:t>
             </a:r>
           </a:p>
           <a:p>
@@ -4774,7 +4774,7 @@
                 </a:solidFill>
                 <a:latin typeface="Aptos"/>
               </a:rPr>
-              <a:t>Positioning: not a broad food-bank AI system, not all 35 problems, and not a generic marketplace.</a:t>
+              <a:t>Positioning: one focused movement problem, solved with inventory-backed listings.</a:t>
             </a:r>
           </a:p>
         </p:txBody>
@@ -4808,7 +4808,7 @@
                 </a:solidFill>
                 <a:latin typeface="Aptos"/>
               </a:rPr>
-              <a:t>Track mapping from local hackathon problem list: Theme 7 Problem 34; Theme 2 Problems 6, 9, 10.</a:t>
+              <a:t>Track mapping: Primary = Theme 7 Problem 34. Enabler = Theme 2 Problems 6, 9, 10.</a:t>
             </a:r>
           </a:p>
         </p:txBody>

</xml_diff>